<commit_message>
Semester 1 PBL wrap
</commit_message>
<xml_diff>
--- a/NUDGE-Intro-Simple.pptx
+++ b/NUDGE-Intro-Simple.pptx
@@ -573,7 +573,7 @@
           <a:lstStyle/>
           <a:p>
             <a:r>
-              <a:t>Andrew (30 sec): Reviews show two things - pain points, and reasons people visit. Some pain points can shrink with clearer information before the trip; that is an information nudge. Others, like crowding, we address by guiding visitors toward quieter good places. We rank these low-cost ideas to test next. This is exploratory: it finds experiments to test, not proof of cause and effect.</a:t>
+              <a:t>Andrew (30 sec): We began with hypotheses, not solutions. For each reviewed aspect, we tested whether its presence was associated with a low star rating. We adjusted for review length, language, and prefecture, then applied an FDR check. Opening hours, itinerary fit, and wayfinding were useful signals for the final ranking. Earlier language-gap tests moved to the appendix. These are exploratory associations, not causal effects.</a:t>
             </a:r>
           </a:p>
         </p:txBody>
@@ -4145,7 +4145,7 @@
                 <a:ea typeface="Century Gothic"/>
                 <a:cs typeface="Century Gothic"/>
               </a:rPr>
-              <a:t>Our approach: small nudges</a:t>
+              <a:t>What we tested</a:t>
             </a:r>
           </a:p>
           <a:p>
@@ -4163,7 +4163,7 @@
                 <a:ea typeface="Yu Gothic"/>
                 <a:cs typeface="Yu Gothic"/>
               </a:rPr>
-              <a:t>私たちの方法:小さなナッジ</a:t>
+              <a:t>私たちが検証したこと</a:t>
             </a:r>
           </a:p>
         </p:txBody>
@@ -4207,7 +4207,7 @@
                 <a:ea typeface="Century Gothic"/>
                 <a:cs typeface="Century Gothic"/>
               </a:rPr>
-              <a:t>•  Reviews show pain points and reasons to visit.</a:t>
+              <a:t>•  We tested whether each review aspect was associated with a low rating.</a:t>
             </a:r>
           </a:p>
           <a:p>
@@ -4228,7 +4228,7 @@
                 <a:ea typeface="Yu Gothic"/>
                 <a:cs typeface="Yu Gothic"/>
               </a:rPr>
-              <a:t>　 口コミは、不満点と訪問の理由を示す。</a:t>
+              <a:t>　 口コミの各要素が低評価と関連するかを検証した。</a:t>
             </a:r>
           </a:p>
           <a:p>
@@ -4249,7 +4249,7 @@
                 <a:ea typeface="Century Gothic"/>
                 <a:cs typeface="Century Gothic"/>
               </a:rPr>
-              <a:t>•  Some pain points shrink with better information before the trip.</a:t>
+              <a:t>•  We adjusted for review length, language, and prefecture.</a:t>
             </a:r>
           </a:p>
           <a:p>
@@ -4270,7 +4270,7 @@
                 <a:ea typeface="Yu Gothic"/>
                 <a:cs typeface="Yu Gothic"/>
               </a:rPr>
-              <a:t>　 一部の不満は、旅行前の分かりやすい情報で減る。</a:t>
+              <a:t>　 口コミの長さ、言語、県を調整した。</a:t>
             </a:r>
           </a:p>
           <a:p>
@@ -4291,7 +4291,7 @@
                 <a:ea typeface="Century Gothic"/>
                 <a:cs typeface="Century Gothic"/>
               </a:rPr>
-              <a:t>•  We rank low-cost ideas (nudges) to test next.</a:t>
+              <a:t>•  We kept harmful associations that passed the FDR check.</a:t>
             </a:r>
           </a:p>
           <a:p>
@@ -4312,7 +4312,7 @@
                 <a:ea typeface="Yu Gothic"/>
                 <a:cs typeface="Yu Gothic"/>
               </a:rPr>
-              <a:t>　 次に検証する、低コストの案(ナッジ)を順位づける。</a:t>
+              <a:t>　 FDR検定を通過した、低評価との関連を残した。</a:t>
             </a:r>
           </a:p>
         </p:txBody>
@@ -4367,7 +4367,7 @@
               </a:spcAft>
             </a:pPr>
             <a:r>
-              <a:rPr sz="1600" b="1" i="0">
+              <a:rPr sz="1450" b="1" i="0">
                 <a:solidFill>
                   <a:srgbClr val="16345E"/>
                 </a:solidFill>
@@ -4375,7 +4375,7 @@
                 <a:ea typeface="Century Gothic"/>
                 <a:cs typeface="Century Gothic"/>
               </a:rPr>
-              <a:t>Information provision</a:t>
+              <a:t>These tests shaped the final ranking.</a:t>
             </a:r>
           </a:p>
           <a:p>
@@ -4393,7 +4393,7 @@
                 <a:ea typeface="Yu Gothic"/>
                 <a:cs typeface="Yu Gothic"/>
               </a:rPr>
-              <a:t>情報提供</a:t>
+              <a:t>この検定結果が最終順位を決めた。</a:t>
             </a:r>
           </a:p>
           <a:p>
@@ -4411,7 +4411,7 @@
                 <a:ea typeface="Century Gothic"/>
                 <a:cs typeface="Century Gothic"/>
               </a:rPr>
-              <a:t>Give clear info before the visit</a:t>
+              <a:t>Opening hours, itinerary fit, and wayfinding passed the FDR check.</a:t>
             </a:r>
           </a:p>
           <a:p>
@@ -4429,7 +4429,7 @@
                 <a:ea typeface="Yu Gothic"/>
                 <a:cs typeface="Yu Gothic"/>
               </a:rPr>
-              <a:t>訪問前に分かりやすい情報を渡す</a:t>
+              <a:t>営業時間、旅程適合、案内表示がFDR検定を通過した。</a:t>
             </a:r>
           </a:p>
         </p:txBody>
@@ -4484,7 +4484,7 @@
               </a:spcAft>
             </a:pPr>
             <a:r>
-              <a:rPr sz="1600" b="1" i="0">
+              <a:rPr sz="1450" b="1" i="0">
                 <a:solidFill>
                   <a:srgbClr val="16345E"/>
                 </a:solidFill>
@@ -4492,7 +4492,7 @@
                 <a:ea typeface="Century Gothic"/>
                 <a:cs typeface="Century Gothic"/>
               </a:rPr>
-              <a:t>Demand redistribution</a:t>
+              <a:t>Earlier language-gap tests moved to the appendix.</a:t>
             </a:r>
           </a:p>
           <a:p>
@@ -4510,7 +4510,7 @@
                 <a:ea typeface="Yu Gothic"/>
                 <a:cs typeface="Yu Gothic"/>
               </a:rPr>
-              <a:t>需要の再配分</a:t>
+              <a:t>以前の言語差検定は付録へ移した。</a:t>
             </a:r>
           </a:p>
           <a:p>
@@ -4528,7 +4528,7 @@
                 <a:ea typeface="Century Gothic"/>
                 <a:cs typeface="Century Gothic"/>
               </a:rPr>
-              <a:t>Guide visitors to quieter good places</a:t>
+              <a:t>Their measurement limits kept them from the headline.</a:t>
             </a:r>
           </a:p>
           <a:p>
@@ -4546,7 +4546,7 @@
                 <a:ea typeface="Yu Gothic"/>
                 <a:cs typeface="Yu Gothic"/>
               </a:rPr>
-              <a:t>空いている良い場所へ誘導する</a:t>
+              <a:t>測定上の限界があるため、主要結果にはしなかった。</a:t>
             </a:r>
           </a:p>
         </p:txBody>
@@ -4612,7 +4612,7 @@
                 <a:ea typeface="Century Gothic"/>
                 <a:cs typeface="Century Gothic"/>
               </a:rPr>
-              <a:t>Exploratory study: it finds experiments to test, not proof of cause and effect.</a:t>
+              <a:t>Exploratory study: these are adjusted associations, not causal effects.</a:t>
             </a:r>
           </a:p>
           <a:p>
@@ -4633,7 +4633,7 @@
                 <a:ea typeface="Yu Gothic"/>
                 <a:cs typeface="Yu Gothic"/>
               </a:rPr>
-              <a:t>探索的研究:検証する実験を見つけるもので、因果関係の証明ではない。</a:t>
+              <a:t>探索的研究:これは調整済みの関連であり、因果効果ではない。</a:t>
             </a:r>
           </a:p>
         </p:txBody>

</xml_diff>